<commit_message>
Actualiza el material de la clase
</commit_message>
<xml_diff>
--- a/Clase 04/3. Estructuras de control.pptx
+++ b/Clase 04/3. Estructuras de control.pptx
@@ -124,20 +124,12 @@
 </p:presentation>
 </file>
 
-<file path=ppt/revisionInfo.xml><?xml version="1.0" encoding="utf-8"?>
-<p1510:revInfo xmlns:a="http://schemas.openxmlformats.org/drawingml/2006/main" xmlns:r="http://schemas.openxmlformats.org/officeDocument/2006/relationships" xmlns:p1510="http://schemas.microsoft.com/office/powerpoint/2015/10/main">
-  <p1510:revLst>
-    <p1510:client id="{BEE5BB87-6DBE-4E9C-954F-080199D5AC26}" v="15" dt="2026-05-06T22:12:15.742"/>
-  </p1510:revLst>
-</p1510:revInfo>
-</file>
-
 <file path=ppt/changesInfos/changesInfo1.xml><?xml version="1.0" encoding="utf-8"?>
 <pc:chgInfo xmlns:a="http://schemas.openxmlformats.org/drawingml/2006/main" xmlns:r="http://schemas.openxmlformats.org/officeDocument/2006/relationships" xmlns:ac="http://schemas.microsoft.com/office/drawing/2013/main/command" xmlns:pc="http://schemas.microsoft.com/office/powerpoint/2013/main/command">
   <pc:docChgLst>
     <pc:chgData name="DANIEL ALBERTO PEREZ MORERA" userId="b71f61fa-2a10-40af-a76c-06b5b43d475d" providerId="ADAL" clId="{CCE38196-6549-48A5-B8F0-4FE1DF2DB2E5}"/>
     <pc:docChg chg="undo redo custSel addSld delSld modSld sldOrd">
-      <pc:chgData name="DANIEL ALBERTO PEREZ MORERA" userId="b71f61fa-2a10-40af-a76c-06b5b43d475d" providerId="ADAL" clId="{CCE38196-6549-48A5-B8F0-4FE1DF2DB2E5}" dt="2026-05-06T21:23:08.848" v="1382" actId="14100"/>
+      <pc:chgData name="DANIEL ALBERTO PEREZ MORERA" userId="b71f61fa-2a10-40af-a76c-06b5b43d475d" providerId="ADAL" clId="{CCE38196-6549-48A5-B8F0-4FE1DF2DB2E5}" dt="2026-05-23T16:43:33.573" v="1388" actId="27636"/>
       <pc:docMkLst>
         <pc:docMk/>
       </pc:docMkLst>
@@ -202,59 +194,9 @@
             <ac:spMk id="12" creationId="{054B3F04-9EAC-45C0-B3CE-0387EEA10A0C}"/>
           </ac:spMkLst>
         </pc:spChg>
-        <pc:picChg chg="add del mod">
-          <ac:chgData name="DANIEL ALBERTO PEREZ MORERA" userId="b71f61fa-2a10-40af-a76c-06b5b43d475d" providerId="ADAL" clId="{CCE38196-6549-48A5-B8F0-4FE1DF2DB2E5}" dt="2026-05-06T20:53:04" v="1221" actId="478"/>
-          <ac:picMkLst>
-            <pc:docMk/>
-            <pc:sldMk cId="1885970478" sldId="269"/>
-            <ac:picMk id="5" creationId="{C3648D67-443F-2668-53E2-F45BB2D0A956}"/>
-          </ac:picMkLst>
-        </pc:picChg>
-      </pc:sldChg>
-      <pc:sldChg chg="addSp delSp modSp add del mod">
-        <pc:chgData name="DANIEL ALBERTO PEREZ MORERA" userId="b71f61fa-2a10-40af-a76c-06b5b43d475d" providerId="ADAL" clId="{CCE38196-6549-48A5-B8F0-4FE1DF2DB2E5}" dt="2026-05-06T21:16:19.563" v="1339" actId="47"/>
-        <pc:sldMkLst>
-          <pc:docMk/>
-          <pc:sldMk cId="1110555708" sldId="270"/>
-        </pc:sldMkLst>
-      </pc:sldChg>
-      <pc:sldChg chg="addSp delSp modSp add del mod">
-        <pc:chgData name="DANIEL ALBERTO PEREZ MORERA" userId="b71f61fa-2a10-40af-a76c-06b5b43d475d" providerId="ADAL" clId="{CCE38196-6549-48A5-B8F0-4FE1DF2DB2E5}" dt="2026-05-06T21:16:19.563" v="1339" actId="47"/>
-        <pc:sldMkLst>
-          <pc:docMk/>
-          <pc:sldMk cId="2924634673" sldId="271"/>
-        </pc:sldMkLst>
-      </pc:sldChg>
-      <pc:sldChg chg="modSp add del mod">
-        <pc:chgData name="DANIEL ALBERTO PEREZ MORERA" userId="b71f61fa-2a10-40af-a76c-06b5b43d475d" providerId="ADAL" clId="{CCE38196-6549-48A5-B8F0-4FE1DF2DB2E5}" dt="2026-05-06T21:16:19.563" v="1339" actId="47"/>
-        <pc:sldMkLst>
-          <pc:docMk/>
-          <pc:sldMk cId="1740098146" sldId="272"/>
-        </pc:sldMkLst>
-      </pc:sldChg>
-      <pc:sldChg chg="modSp add del mod ord">
-        <pc:chgData name="DANIEL ALBERTO PEREZ MORERA" userId="b71f61fa-2a10-40af-a76c-06b5b43d475d" providerId="ADAL" clId="{CCE38196-6549-48A5-B8F0-4FE1DF2DB2E5}" dt="2026-05-06T21:16:19.563" v="1339" actId="47"/>
-        <pc:sldMkLst>
-          <pc:docMk/>
-          <pc:sldMk cId="2474678990" sldId="273"/>
-        </pc:sldMkLst>
-      </pc:sldChg>
-      <pc:sldChg chg="add del">
-        <pc:chgData name="DANIEL ALBERTO PEREZ MORERA" userId="b71f61fa-2a10-40af-a76c-06b5b43d475d" providerId="ADAL" clId="{CCE38196-6549-48A5-B8F0-4FE1DF2DB2E5}" dt="2026-05-06T21:16:19.563" v="1339" actId="47"/>
-        <pc:sldMkLst>
-          <pc:docMk/>
-          <pc:sldMk cId="1211649159" sldId="274"/>
-        </pc:sldMkLst>
-      </pc:sldChg>
-      <pc:sldChg chg="addSp delSp modSp add del mod">
-        <pc:chgData name="DANIEL ALBERTO PEREZ MORERA" userId="b71f61fa-2a10-40af-a76c-06b5b43d475d" providerId="ADAL" clId="{CCE38196-6549-48A5-B8F0-4FE1DF2DB2E5}" dt="2026-05-06T21:16:19.563" v="1339" actId="47"/>
-        <pc:sldMkLst>
-          <pc:docMk/>
-          <pc:sldMk cId="1773553698" sldId="275"/>
-        </pc:sldMkLst>
       </pc:sldChg>
       <pc:sldChg chg="addSp delSp modSp new mod">
-        <pc:chgData name="DANIEL ALBERTO PEREZ MORERA" userId="b71f61fa-2a10-40af-a76c-06b5b43d475d" providerId="ADAL" clId="{CCE38196-6549-48A5-B8F0-4FE1DF2DB2E5}" dt="2026-05-06T21:23:08.848" v="1382" actId="14100"/>
+        <pc:chgData name="DANIEL ALBERTO PEREZ MORERA" userId="b71f61fa-2a10-40af-a76c-06b5b43d475d" providerId="ADAL" clId="{CCE38196-6549-48A5-B8F0-4FE1DF2DB2E5}" dt="2026-05-23T16:43:33.573" v="1388" actId="27636"/>
         <pc:sldMkLst>
           <pc:docMk/>
           <pc:sldMk cId="1100032990" sldId="276"/>
@@ -268,27 +210,11 @@
           </ac:spMkLst>
         </pc:spChg>
         <pc:spChg chg="mod">
-          <ac:chgData name="DANIEL ALBERTO PEREZ MORERA" userId="b71f61fa-2a10-40af-a76c-06b5b43d475d" providerId="ADAL" clId="{CCE38196-6549-48A5-B8F0-4FE1DF2DB2E5}" dt="2026-05-06T21:23:08.848" v="1382" actId="14100"/>
+          <ac:chgData name="DANIEL ALBERTO PEREZ MORERA" userId="b71f61fa-2a10-40af-a76c-06b5b43d475d" providerId="ADAL" clId="{CCE38196-6549-48A5-B8F0-4FE1DF2DB2E5}" dt="2026-05-23T16:43:33.573" v="1388" actId="27636"/>
           <ac:spMkLst>
             <pc:docMk/>
             <pc:sldMk cId="1100032990" sldId="276"/>
             <ac:spMk id="3" creationId="{8A74FB23-DAA6-14D7-0050-88F3EA357EC9}"/>
-          </ac:spMkLst>
-        </pc:spChg>
-        <pc:spChg chg="del mod">
-          <ac:chgData name="DANIEL ALBERTO PEREZ MORERA" userId="b71f61fa-2a10-40af-a76c-06b5b43d475d" providerId="ADAL" clId="{CCE38196-6549-48A5-B8F0-4FE1DF2DB2E5}" dt="2026-05-06T21:22:36.749" v="1379" actId="478"/>
-          <ac:spMkLst>
-            <pc:docMk/>
-            <pc:sldMk cId="1100032990" sldId="276"/>
-            <ac:spMk id="4" creationId="{09F7C62D-F815-5F1E-3D89-29B85657B257}"/>
-          </ac:spMkLst>
-        </pc:spChg>
-        <pc:spChg chg="add del mod">
-          <ac:chgData name="DANIEL ALBERTO PEREZ MORERA" userId="b71f61fa-2a10-40af-a76c-06b5b43d475d" providerId="ADAL" clId="{CCE38196-6549-48A5-B8F0-4FE1DF2DB2E5}" dt="2026-05-06T21:22:39.432" v="1380" actId="478"/>
-          <ac:spMkLst>
-            <pc:docMk/>
-            <pc:sldMk cId="1100032990" sldId="276"/>
-            <ac:spMk id="6" creationId="{E36DE739-B7DC-578D-56B2-D1528422A1B2}"/>
           </ac:spMkLst>
         </pc:spChg>
       </pc:sldChg>
@@ -312,30 +238,6 @@
             <pc:docMk/>
             <pc:sldMk cId="3537006609" sldId="277"/>
             <ac:spMk id="3" creationId="{BCF177CF-93D3-1D9C-3AE9-EDF7BC4F8ADE}"/>
-          </ac:spMkLst>
-        </pc:spChg>
-        <pc:spChg chg="del">
-          <ac:chgData name="DANIEL ALBERTO PEREZ MORERA" userId="b71f61fa-2a10-40af-a76c-06b5b43d475d" providerId="ADAL" clId="{CCE38196-6549-48A5-B8F0-4FE1DF2DB2E5}" dt="2026-05-06T20:56:56.172" v="1240" actId="26606"/>
-          <ac:spMkLst>
-            <pc:docMk/>
-            <pc:sldMk cId="3537006609" sldId="277"/>
-            <ac:spMk id="8" creationId="{DCCF5A00-94A4-53D9-4812-E52234F47298}"/>
-          </ac:spMkLst>
-        </pc:spChg>
-        <pc:spChg chg="del">
-          <ac:chgData name="DANIEL ALBERTO PEREZ MORERA" userId="b71f61fa-2a10-40af-a76c-06b5b43d475d" providerId="ADAL" clId="{CCE38196-6549-48A5-B8F0-4FE1DF2DB2E5}" dt="2026-05-06T20:56:56.172" v="1240" actId="26606"/>
-          <ac:spMkLst>
-            <pc:docMk/>
-            <pc:sldMk cId="3537006609" sldId="277"/>
-            <ac:spMk id="10" creationId="{64964705-9F2C-AEF3-7A71-9F24A80B17B1}"/>
-          </ac:spMkLst>
-        </pc:spChg>
-        <pc:spChg chg="del">
-          <ac:chgData name="DANIEL ALBERTO PEREZ MORERA" userId="b71f61fa-2a10-40af-a76c-06b5b43d475d" providerId="ADAL" clId="{CCE38196-6549-48A5-B8F0-4FE1DF2DB2E5}" dt="2026-05-06T20:56:56.172" v="1240" actId="26606"/>
-          <ac:spMkLst>
-            <pc:docMk/>
-            <pc:sldMk cId="3537006609" sldId="277"/>
-            <ac:spMk id="12" creationId="{1134D66B-2C67-0AAE-6A7E-8A903D6802C2}"/>
           </ac:spMkLst>
         </pc:spChg>
         <pc:spChg chg="add">
@@ -393,14 +295,6 @@
             <ac:spMk id="3" creationId="{E73FADEB-277E-A448-7D51-39B70F794760}"/>
           </ac:spMkLst>
         </pc:spChg>
-        <pc:picChg chg="del">
-          <ac:chgData name="DANIEL ALBERTO PEREZ MORERA" userId="b71f61fa-2a10-40af-a76c-06b5b43d475d" providerId="ADAL" clId="{CCE38196-6549-48A5-B8F0-4FE1DF2DB2E5}" dt="2026-05-06T20:59:46.068" v="1255" actId="478"/>
-          <ac:picMkLst>
-            <pc:docMk/>
-            <pc:sldMk cId="296176996" sldId="278"/>
-            <ac:picMk id="5" creationId="{2581C7FE-F9B5-32AA-4A29-5F6616C87551}"/>
-          </ac:picMkLst>
-        </pc:picChg>
         <pc:picChg chg="add mod">
           <ac:chgData name="DANIEL ALBERTO PEREZ MORERA" userId="b71f61fa-2a10-40af-a76c-06b5b43d475d" providerId="ADAL" clId="{CCE38196-6549-48A5-B8F0-4FE1DF2DB2E5}" dt="2026-05-06T20:59:54.925" v="1258" actId="1076"/>
           <ac:picMkLst>
@@ -432,22 +326,6 @@
             <ac:spMk id="3" creationId="{D5EC163C-61F8-F07A-78E5-01D92F96313C}"/>
           </ac:spMkLst>
         </pc:spChg>
-        <pc:spChg chg="add del">
-          <ac:chgData name="DANIEL ALBERTO PEREZ MORERA" userId="b71f61fa-2a10-40af-a76c-06b5b43d475d" providerId="ADAL" clId="{CCE38196-6549-48A5-B8F0-4FE1DF2DB2E5}" dt="2026-05-06T21:01:20.906" v="1261" actId="22"/>
-          <ac:spMkLst>
-            <pc:docMk/>
-            <pc:sldMk cId="3595318667" sldId="279"/>
-            <ac:spMk id="5" creationId="{DD41D212-ECDA-57E8-968C-90F3EDA63E05}"/>
-          </ac:spMkLst>
-        </pc:spChg>
-        <pc:picChg chg="del">
-          <ac:chgData name="DANIEL ALBERTO PEREZ MORERA" userId="b71f61fa-2a10-40af-a76c-06b5b43d475d" providerId="ADAL" clId="{CCE38196-6549-48A5-B8F0-4FE1DF2DB2E5}" dt="2026-05-06T21:04:02.097" v="1266" actId="478"/>
-          <ac:picMkLst>
-            <pc:docMk/>
-            <pc:sldMk cId="3595318667" sldId="279"/>
-            <ac:picMk id="6" creationId="{4A75DCD1-843C-17C5-7C3C-811C1A2A8B07}"/>
-          </ac:picMkLst>
-        </pc:picChg>
         <pc:picChg chg="add mod">
           <ac:chgData name="DANIEL ALBERTO PEREZ MORERA" userId="b71f61fa-2a10-40af-a76c-06b5b43d475d" providerId="ADAL" clId="{CCE38196-6549-48A5-B8F0-4FE1DF2DB2E5}" dt="2026-05-06T21:04:13.288" v="1270" actId="1076"/>
           <ac:picMkLst>
@@ -502,28 +380,12 @@
             <ac:spMk id="3" creationId="{5C0C6609-2B2E-EC45-43E7-C686F06B9FD7}"/>
           </ac:spMkLst>
         </pc:spChg>
-        <pc:picChg chg="add del">
-          <ac:chgData name="DANIEL ALBERTO PEREZ MORERA" userId="b71f61fa-2a10-40af-a76c-06b5b43d475d" providerId="ADAL" clId="{CCE38196-6549-48A5-B8F0-4FE1DF2DB2E5}" dt="2026-05-06T21:10:07.671" v="1303" actId="478"/>
-          <ac:picMkLst>
-            <pc:docMk/>
-            <pc:sldMk cId="866859736" sldId="281"/>
-            <ac:picMk id="5" creationId="{AFB40139-997F-F2A9-7FE8-9BC99902EB51}"/>
-          </ac:picMkLst>
-        </pc:picChg>
         <pc:picChg chg="add mod">
           <ac:chgData name="DANIEL ALBERTO PEREZ MORERA" userId="b71f61fa-2a10-40af-a76c-06b5b43d475d" providerId="ADAL" clId="{CCE38196-6549-48A5-B8F0-4FE1DF2DB2E5}" dt="2026-05-06T21:10:13.143" v="1305" actId="1076"/>
           <ac:picMkLst>
             <pc:docMk/>
             <pc:sldMk cId="866859736" sldId="281"/>
             <ac:picMk id="7" creationId="{8B6C317C-160E-683E-DA58-24C40875C4C7}"/>
-          </ac:picMkLst>
-        </pc:picChg>
-        <pc:picChg chg="del">
-          <ac:chgData name="DANIEL ALBERTO PEREZ MORERA" userId="b71f61fa-2a10-40af-a76c-06b5b43d475d" providerId="ADAL" clId="{CCE38196-6549-48A5-B8F0-4FE1DF2DB2E5}" dt="2026-05-06T21:09:59.212" v="1301" actId="478"/>
-          <ac:picMkLst>
-            <pc:docMk/>
-            <pc:sldMk cId="866859736" sldId="281"/>
-            <ac:picMk id="8" creationId="{743974ED-700A-78E2-A571-3904B62B8FAE}"/>
           </ac:picMkLst>
         </pc:picChg>
       </pc:sldChg>
@@ -557,14 +419,6 @@
             <ac:picMk id="5" creationId="{55DE9A35-63B6-520D-8990-53E0CBA8F01B}"/>
           </ac:picMkLst>
         </pc:picChg>
-        <pc:picChg chg="del">
-          <ac:chgData name="DANIEL ALBERTO PEREZ MORERA" userId="b71f61fa-2a10-40af-a76c-06b5b43d475d" providerId="ADAL" clId="{CCE38196-6549-48A5-B8F0-4FE1DF2DB2E5}" dt="2026-05-06T21:14:25.158" v="1323" actId="478"/>
-          <ac:picMkLst>
-            <pc:docMk/>
-            <pc:sldMk cId="4209304406" sldId="282"/>
-            <ac:picMk id="7" creationId="{DC7B2614-9428-66EA-2D68-98A94AA39182}"/>
-          </ac:picMkLst>
-        </pc:picChg>
       </pc:sldChg>
       <pc:sldChg chg="addSp delSp modSp add mod">
         <pc:chgData name="DANIEL ALBERTO PEREZ MORERA" userId="b71f61fa-2a10-40af-a76c-06b5b43d475d" providerId="ADAL" clId="{CCE38196-6549-48A5-B8F0-4FE1DF2DB2E5}" dt="2026-05-06T21:16:11.950" v="1338" actId="1076"/>
@@ -588,14 +442,6 @@
             <ac:spMk id="3" creationId="{52E6333C-A51E-2389-1F2A-2C229A42B392}"/>
           </ac:spMkLst>
         </pc:spChg>
-        <pc:picChg chg="del">
-          <ac:chgData name="DANIEL ALBERTO PEREZ MORERA" userId="b71f61fa-2a10-40af-a76c-06b5b43d475d" providerId="ADAL" clId="{CCE38196-6549-48A5-B8F0-4FE1DF2DB2E5}" dt="2026-05-06T21:16:05.518" v="1336" actId="478"/>
-          <ac:picMkLst>
-            <pc:docMk/>
-            <pc:sldMk cId="819245608" sldId="283"/>
-            <ac:picMk id="5" creationId="{081FFD94-495B-0064-D6BA-E46397CD0428}"/>
-          </ac:picMkLst>
-        </pc:picChg>
         <pc:picChg chg="add mod">
           <ac:chgData name="DANIEL ALBERTO PEREZ MORERA" userId="b71f61fa-2a10-40af-a76c-06b5b43d475d" providerId="ADAL" clId="{CCE38196-6549-48A5-B8F0-4FE1DF2DB2E5}" dt="2026-05-06T21:16:11.950" v="1338" actId="1076"/>
           <ac:picMkLst>
@@ -692,7 +538,7 @@
           <a:p>
             <a:fld id="{60D73BB4-624C-4056-8D37-621F995BF4BB}" type="datetimeFigureOut">
               <a:rPr lang="en-US" smtClean="0"/>
-              <a:t>5/6/2026</a:t>
+              <a:t>5/23/2026</a:t>
             </a:fld>
             <a:endParaRPr lang="en-US"/>
           </a:p>
@@ -1199,7 +1045,7 @@
           <a:p>
             <a:fld id="{51ECB181-E4EF-43AF-A2BE-59DB96048CA2}" type="datetimeFigureOut">
               <a:rPr lang="en-US" smtClean="0"/>
-              <a:t>5/6/2026</a:t>
+              <a:t>5/23/2026</a:t>
             </a:fld>
             <a:endParaRPr lang="en-US"/>
           </a:p>
@@ -1407,7 +1253,7 @@
           <a:p>
             <a:fld id="{51ECB181-E4EF-43AF-A2BE-59DB96048CA2}" type="datetimeFigureOut">
               <a:rPr lang="en-US" smtClean="0"/>
-              <a:t>5/6/2026</a:t>
+              <a:t>5/23/2026</a:t>
             </a:fld>
             <a:endParaRPr lang="en-US"/>
           </a:p>
@@ -1677,7 +1523,7 @@
           <a:p>
             <a:fld id="{51ECB181-E4EF-43AF-A2BE-59DB96048CA2}" type="datetimeFigureOut">
               <a:rPr lang="en-US" smtClean="0"/>
-              <a:t>5/6/2026</a:t>
+              <a:t>5/23/2026</a:t>
             </a:fld>
             <a:endParaRPr lang="en-US"/>
           </a:p>
@@ -1847,7 +1693,7 @@
           <a:p>
             <a:fld id="{51ECB181-E4EF-43AF-A2BE-59DB96048CA2}" type="datetimeFigureOut">
               <a:rPr lang="en-US" smtClean="0"/>
-              <a:t>5/6/2026</a:t>
+              <a:t>5/23/2026</a:t>
             </a:fld>
             <a:endParaRPr lang="en-US"/>
           </a:p>
@@ -2204,7 +2050,7 @@
           <a:p>
             <a:fld id="{51ECB181-E4EF-43AF-A2BE-59DB96048CA2}" type="datetimeFigureOut">
               <a:rPr lang="en-US" smtClean="0"/>
-              <a:t>5/6/2026</a:t>
+              <a:t>5/23/2026</a:t>
             </a:fld>
             <a:endParaRPr lang="en-US"/>
           </a:p>
@@ -2479,7 +2325,7 @@
           <a:p>
             <a:fld id="{51ECB181-E4EF-43AF-A2BE-59DB96048CA2}" type="datetimeFigureOut">
               <a:rPr lang="en-US" smtClean="0"/>
-              <a:t>5/6/2026</a:t>
+              <a:t>5/23/2026</a:t>
             </a:fld>
             <a:endParaRPr lang="en-US"/>
           </a:p>
@@ -2858,7 +2704,7 @@
           <a:p>
             <a:fld id="{51ECB181-E4EF-43AF-A2BE-59DB96048CA2}" type="datetimeFigureOut">
               <a:rPr lang="en-US" smtClean="0"/>
-              <a:t>5/6/2026</a:t>
+              <a:t>5/23/2026</a:t>
             </a:fld>
             <a:endParaRPr lang="en-US"/>
           </a:p>
@@ -2976,7 +2822,7 @@
           <a:p>
             <a:fld id="{51ECB181-E4EF-43AF-A2BE-59DB96048CA2}" type="datetimeFigureOut">
               <a:rPr lang="en-US" smtClean="0"/>
-              <a:t>5/6/2026</a:t>
+              <a:t>5/23/2026</a:t>
             </a:fld>
             <a:endParaRPr lang="en-US"/>
           </a:p>
@@ -3161,7 +3007,7 @@
           <a:p>
             <a:fld id="{51ECB181-E4EF-43AF-A2BE-59DB96048CA2}" type="datetimeFigureOut">
               <a:rPr lang="en-US" smtClean="0"/>
-              <a:t>5/6/2026</a:t>
+              <a:t>5/23/2026</a:t>
             </a:fld>
             <a:endParaRPr lang="en-US"/>
           </a:p>
@@ -3529,7 +3375,7 @@
           <a:p>
             <a:fld id="{51ECB181-E4EF-43AF-A2BE-59DB96048CA2}" type="datetimeFigureOut">
               <a:rPr lang="en-US" smtClean="0"/>
-              <a:t>5/6/2026</a:t>
+              <a:t>5/23/2026</a:t>
             </a:fld>
             <a:endParaRPr lang="en-US"/>
           </a:p>
@@ -3920,7 +3766,7 @@
           <a:p>
             <a:fld id="{51ECB181-E4EF-43AF-A2BE-59DB96048CA2}" type="datetimeFigureOut">
               <a:rPr lang="en-US" smtClean="0"/>
-              <a:t>5/6/2026</a:t>
+              <a:t>5/23/2026</a:t>
             </a:fld>
             <a:endParaRPr lang="en-US"/>
           </a:p>
@@ -4221,7 +4067,7 @@
           <a:p>
             <a:fld id="{51ECB181-E4EF-43AF-A2BE-59DB96048CA2}" type="datetimeFigureOut">
               <a:rPr lang="en-US" smtClean="0"/>
-              <a:t>5/6/2026</a:t>
+              <a:t>5/23/2026</a:t>
             </a:fld>
             <a:endParaRPr lang="en-US"/>
           </a:p>
@@ -4902,42 +4748,42 @@
           <a:lstStyle/>
           <a:p>
             <a:r>
-              <a:rPr lang="es-ES" dirty="0"/>
+              <a:rPr lang="es-ES" sz="2800" dirty="0"/>
               <a:t>Desarrolle un programa que simule el funcionamiento básico de un cajero automático</a:t>
             </a:r>
             <a:r>
-              <a:rPr lang="en-US" dirty="0"/>
+              <a:rPr lang="en-US" sz="2800" dirty="0"/>
               <a:t>.</a:t>
             </a:r>
           </a:p>
           <a:p>
             <a:pPr lvl="1"/>
             <a:r>
-              <a:rPr lang="es-ES" dirty="0"/>
+              <a:rPr lang="es-ES" sz="2400" dirty="0"/>
               <a:t>El sistema debe permitir al usuario realizar distintas operaciones sobre una cuenta con un saldo inicial definido.</a:t>
             </a:r>
           </a:p>
           <a:p>
             <a:pPr lvl="1"/>
             <a:r>
-              <a:rPr lang="es-ES" dirty="0"/>
+              <a:rPr lang="es-ES" sz="2400" dirty="0"/>
               <a:t>El programa debe mostrar un menú de opciones de forma repetitiva hasta que el usuario decida salir.</a:t>
             </a:r>
           </a:p>
           <a:p>
             <a:pPr lvl="1"/>
             <a:r>
-              <a:rPr lang="es-ES" dirty="0"/>
+              <a:rPr lang="es-ES" sz="2400" dirty="0"/>
               <a:t>Las opciones disponibles son: Consultar saldo, Depositar dinero, Retirar dinero y Salir.</a:t>
             </a:r>
           </a:p>
           <a:p>
             <a:pPr lvl="1"/>
             <a:r>
-              <a:rPr lang="es-ES" dirty="0"/>
+              <a:rPr lang="es-ES" sz="2400" dirty="0"/>
               <a:t>El usuario deberá seleccionar una opción e ingresar los datos necesarios según el caso.</a:t>
             </a:r>
-            <a:endParaRPr lang="en-US" dirty="0"/>
+            <a:endParaRPr lang="en-US" sz="2400" dirty="0"/>
           </a:p>
         </p:txBody>
       </p:sp>

</xml_diff>